<commit_message>
docs: add USER_GUIDE.md and commit updated roadshow deck
USER_GUIDE.md covers the full tool end-to-end:
- Getting started (setup, .env, first run)
- Manual conversion walkthrough (12 steps + 3 gates)
- Scheduled ingestion via file watcher + manifest format
- Webhook notifications and GitHub PR integration
- Testing artifacts overview (pointer to TESTING_GUIDE.md)
- Full configuration reference table for all .env variables
- FAQ covering common operator questions

Co-Authored-By: Claude Sonnet 4.6 <noreply@anthropic.com>
</commit_message>
<xml_diff>
--- a/docs/Informatica Conversion Tool - Internal Roadshow.pptx
+++ b/docs/Informatica Conversion Tool - Internal Roadshow.pptx
@@ -1652,7 +1652,7 @@
                   <a:srgbClr val="FFFFFF"/>
                 </a:solidFill>
               </a:rPr>
-              <a:t>12  </a:t>
+              <a:t xml:space="preserve">12  </a:t>
             </a:r>
             <a:pPr indent="0" marL="0">
               <a:buNone/>
@@ -1721,7 +1721,7 @@
                   <a:srgbClr val="FFFFFF"/>
                 </a:solidFill>
               </a:rPr>
-              <a:t>3  </a:t>
+              <a:t xml:space="preserve">3  </a:t>
             </a:r>
             <a:pPr indent="0" marL="0">
               <a:buNone/>
@@ -1790,7 +1790,7 @@
                   <a:srgbClr val="FFFFFF"/>
                 </a:solidFill>
               </a:rPr>
-              <a:t>3  </a:t>
+              <a:t xml:space="preserve">3  </a:t>
             </a:r>
             <a:pPr indent="0" marL="0">
               <a:buNone/>
@@ -1859,7 +1859,7 @@
                   <a:srgbClr val="FFFFFF"/>
                 </a:solidFill>
               </a:rPr>
-              <a:t>100%  </a:t>
+              <a:t xml:space="preserve">100%  </a:t>
             </a:r>
             <a:pPr indent="0" marL="0">
               <a:buNone/>
@@ -7369,7 +7369,7 @@
                 <a:ea typeface="Calibri" pitchFamily="34" charset="-122"/>
                 <a:cs typeface="Calibri" pitchFamily="34" charset="-120"/>
               </a:rPr>
-              <a:t>Batch Processing</a:t>
+              <a:t>Batch Processing &amp; Mapplet Support</a:t>
             </a:r>
             <a:endParaRPr lang="en-US" sz="1500" dirty="0"/>
           </a:p>
@@ -7408,7 +7408,7 @@
                 <a:ea typeface="Calibri" pitchFamily="34" charset="-122"/>
                 <a:cs typeface="Calibri" pitchFamily="34" charset="-120"/>
               </a:rPr>
-              <a:t>Jobs are submitted individually or in bulk via the Batch API. The orchestrator processes jobs concurrently with configurable parallelism. A single batch manifest covers all included mappings, and the batch ZIP contains all conversion outputs in one download.</a:t>
+              <a:t>Jobs run individually or in bulk via the Batch API with configurable parallelism. Mapplet inline expansion (v2.12) resolves reusable sub-mappings directly into the graph — no black-box references reach the conversion agent. The batch ZIP contains all outputs in one download.</a:t>
             </a:r>
             <a:endParaRPr lang="en-US" sz="1100" dirty="0"/>
           </a:p>
@@ -7499,7 +7499,7 @@
                 <a:ea typeface="Calibri" pitchFamily="34" charset="-122"/>
                 <a:cs typeface="Calibri" pitchFamily="34" charset="-120"/>
               </a:rPr>
-              <a:t>Pre-Conversion Manifest</a:t>
+              <a:t>Integrations &amp; Notifications</a:t>
             </a:r>
             <a:endParaRPr lang="en-US" sz="1500" dirty="0"/>
           </a:p>
@@ -7538,7 +7538,7 @@
                 <a:ea typeface="Calibri" pitchFamily="34" charset="-122"/>
                 <a:cs typeface="Calibri" pitchFamily="34" charset="-120"/>
               </a:rPr>
-              <a:t>Before a single line of code is generated, the tool produces a signed manifest listing every mapping, its assigned stack, complexity tier, and validation status. Operators review what will be converted and approve the scope — no surprises at delivery.</a:t>
+              <a:t>Webhook notifications (v2.9) fire at every gate pause, failure, and completion — integrate with Slack, Teams, or any HTTP endpoint. GitHub PR integration (v2.10) auto-opens a draft pull request with all generated code after Gate 3 approval. GitHub Enterprise supported.</a:t>
             </a:r>
             <a:endParaRPr lang="en-US" sz="1100" dirty="0"/>
           </a:p>
@@ -8058,7 +8058,7 @@
                 <a:ea typeface="Calibri" pitchFamily="34" charset="-122"/>
                 <a:cs typeface="Calibri" pitchFamily="34" charset="-120"/>
               </a:rPr>
-              <a:t>v2.7</a:t>
+              <a:t>v2.12</a:t>
             </a:r>
             <a:endParaRPr lang="en-US" sz="3000" dirty="0"/>
           </a:p>

</xml_diff>